<commit_message>
Add internals slide and presenter notes to Session 8 (tuples, sets, dicts)
Made-with: Cursor
</commit_message>
<xml_diff>
--- a/Session8_Tuples_Sets_Dictionaries.pptx
+++ b/Session8_Tuples_Sets_Dictionaries.pptx
@@ -8,12 +8,13 @@
     <p:sldId id="256" r:id="rId7"/>
     <p:sldId id="257" r:id="rId8"/>
     <p:sldId id="258" r:id="rId9"/>
-    <p:sldId id="259" r:id="rId10"/>
-    <p:sldId id="260" r:id="rId11"/>
-    <p:sldId id="261" r:id="rId12"/>
-    <p:sldId id="262" r:id="rId13"/>
-    <p:sldId id="263" r:id="rId14"/>
-    <p:sldId id="264" r:id="rId15"/>
+    <p:sldId id="259" r:id="rId11"/>
+    <p:sldId id="260" r:id="rId12"/>
+    <p:sldId id="261" r:id="rId13"/>
+    <p:sldId id="262" r:id="rId14"/>
+    <p:sldId id="263" r:id="rId15"/>
+    <p:sldId id="264" r:id="rId16"/>
+    <p:sldId id="265" r:id="rId17"/>
   </p:sldIdLst>
   <p:sldSz cx="9144000" cy="6858000" type="screen4x3"/>
   <p:notesSz cx="6858000" cy="9144000"/>
@@ -113,6 +114,714 @@
     </a:lvl9pPr>
   </p:defaultTextStyle>
 </p:presentation>
+</file>
+
+<file path=ppt/notesMasters/notesMaster1.xml><?xml version="1.0" encoding="utf-8"?>
+<p:notesMaster xmlns:a="http://schemas.openxmlformats.org/drawingml/2006/main" xmlns:p="http://schemas.openxmlformats.org/presentationml/2006/main" xmlns:r="http://schemas.openxmlformats.org/officeDocument/2006/relationships">
+  <p:cSld>
+    <p:bg>
+      <p:bgRef idx="1001">
+        <a:schemeClr val="bg1"/>
+      </p:bgRef>
+    </p:bg>
+    <p:spTree>
+      <p:nvGrpSpPr>
+        <p:cNvPr id="1" name=""/>
+        <p:cNvGrpSpPr/>
+        <p:nvPr/>
+      </p:nvGrpSpPr>
+      <p:grpSpPr>
+        <a:xfrm>
+          <a:off x="0" y="0"/>
+          <a:ext cx="0" cy="0"/>
+          <a:chOff x="0" y="0"/>
+          <a:chExt cx="0" cy="0"/>
+        </a:xfrm>
+      </p:grpSpPr>
+      <p:sp>
+        <p:nvSpPr>
+          <p:cNvPr id="2" name="Header Placeholder 1"/>
+          <p:cNvSpPr>
+            <a:spLocks noGrp="1"/>
+          </p:cNvSpPr>
+          <p:nvPr>
+            <p:ph type="hdr" sz="quarter"/>
+          </p:nvPr>
+        </p:nvSpPr>
+        <p:spPr>
+          <a:xfrm>
+            <a:off x="0" y="0"/>
+            <a:ext cx="2971800" cy="457200"/>
+          </a:xfrm>
+          <a:prstGeom prst="rect">
+            <a:avLst/>
+          </a:prstGeom>
+        </p:spPr>
+        <p:txBody>
+          <a:bodyPr vert="horz" lIns="91440" tIns="45720" rIns="91440" bIns="45720" rtlCol="0"/>
+          <a:lstStyle>
+            <a:lvl1pPr algn="l">
+              <a:defRPr sz="1200"/>
+            </a:lvl1pPr>
+          </a:lstStyle>
+          <a:p>
+            <a:endParaRPr lang="en-US"/>
+          </a:p>
+        </p:txBody>
+      </p:sp>
+      <p:sp>
+        <p:nvSpPr>
+          <p:cNvPr id="3" name="Date Placeholder 2"/>
+          <p:cNvSpPr>
+            <a:spLocks noGrp="1"/>
+          </p:cNvSpPr>
+          <p:nvPr>
+            <p:ph type="dt" idx="1"/>
+          </p:nvPr>
+        </p:nvSpPr>
+        <p:spPr>
+          <a:xfrm>
+            <a:off x="3884613" y="0"/>
+            <a:ext cx="2971800" cy="457200"/>
+          </a:xfrm>
+          <a:prstGeom prst="rect">
+            <a:avLst/>
+          </a:prstGeom>
+        </p:spPr>
+        <p:txBody>
+          <a:bodyPr vert="horz" lIns="91440" tIns="45720" rIns="91440" bIns="45720" rtlCol="0"/>
+          <a:lstStyle>
+            <a:lvl1pPr algn="r">
+              <a:defRPr sz="1200"/>
+            </a:lvl1pPr>
+          </a:lstStyle>
+          <a:p>
+            <a:fld id="{0F89C1C7-3DCD-1040-A9CF-14679D8B5DDD}" type="datetimeFigureOut">
+              <a:rPr lang="en-US" smtClean="0"/>
+              <a:t>10/17/16</a:t>
+            </a:fld>
+            <a:endParaRPr lang="en-US"/>
+          </a:p>
+        </p:txBody>
+      </p:sp>
+      <p:sp>
+        <p:nvSpPr>
+          <p:cNvPr id="4" name="Slide Image Placeholder 3"/>
+          <p:cNvSpPr>
+            <a:spLocks noGrp="1" noRot="1" noChangeAspect="1"/>
+          </p:cNvSpPr>
+          <p:nvPr>
+            <p:ph type="sldImg" idx="2"/>
+          </p:nvPr>
+        </p:nvSpPr>
+        <p:spPr>
+          <a:xfrm>
+            <a:off x="1143000" y="685800"/>
+            <a:ext cx="4572000" cy="3429000"/>
+          </a:xfrm>
+          <a:prstGeom prst="rect">
+            <a:avLst/>
+          </a:prstGeom>
+          <a:noFill/>
+          <a:ln w="12700">
+            <a:solidFill>
+              <a:prstClr val="black"/>
+            </a:solidFill>
+          </a:ln>
+        </p:spPr>
+        <p:txBody>
+          <a:bodyPr vert="horz" lIns="91440" tIns="45720" rIns="91440" bIns="45720" rtlCol="0" anchor="ctr"/>
+          <a:lstStyle/>
+          <a:p>
+            <a:endParaRPr lang="en-US"/>
+          </a:p>
+        </p:txBody>
+      </p:sp>
+      <p:sp>
+        <p:nvSpPr>
+          <p:cNvPr id="5" name="Notes Placeholder 4"/>
+          <p:cNvSpPr>
+            <a:spLocks noGrp="1"/>
+          </p:cNvSpPr>
+          <p:nvPr>
+            <p:ph type="body" sz="quarter" idx="3"/>
+          </p:nvPr>
+        </p:nvSpPr>
+        <p:spPr>
+          <a:xfrm>
+            <a:off x="685800" y="4343400"/>
+            <a:ext cx="5486400" cy="4114800"/>
+          </a:xfrm>
+          <a:prstGeom prst="rect">
+            <a:avLst/>
+          </a:prstGeom>
+        </p:spPr>
+        <p:txBody>
+          <a:bodyPr vert="horz" lIns="91440" tIns="45720" rIns="91440" bIns="45720" rtlCol="0"/>
+          <a:lstStyle/>
+          <a:p>
+            <a:pPr lvl="0"/>
+            <a:r>
+              <a:rPr lang="en-US" smtClean="0"/>
+              <a:t>Click to edit Master text styles</a:t>
+            </a:r>
+          </a:p>
+          <a:p>
+            <a:pPr lvl="1"/>
+            <a:r>
+              <a:rPr lang="en-US" smtClean="0"/>
+              <a:t>Second level</a:t>
+            </a:r>
+          </a:p>
+          <a:p>
+            <a:pPr lvl="2"/>
+            <a:r>
+              <a:rPr lang="en-US" smtClean="0"/>
+              <a:t>Third level</a:t>
+            </a:r>
+          </a:p>
+          <a:p>
+            <a:pPr lvl="3"/>
+            <a:r>
+              <a:rPr lang="en-US" smtClean="0"/>
+              <a:t>Fourth level</a:t>
+            </a:r>
+          </a:p>
+          <a:p>
+            <a:pPr lvl="4"/>
+            <a:r>
+              <a:rPr lang="en-US" smtClean="0"/>
+              <a:t>Fifth level</a:t>
+            </a:r>
+            <a:endParaRPr lang="en-US"/>
+          </a:p>
+        </p:txBody>
+      </p:sp>
+      <p:sp>
+        <p:nvSpPr>
+          <p:cNvPr id="6" name="Footer Placeholder 5"/>
+          <p:cNvSpPr>
+            <a:spLocks noGrp="1"/>
+          </p:cNvSpPr>
+          <p:nvPr>
+            <p:ph type="ftr" sz="quarter" idx="4"/>
+          </p:nvPr>
+        </p:nvSpPr>
+        <p:spPr>
+          <a:xfrm>
+            <a:off x="0" y="8685213"/>
+            <a:ext cx="2971800" cy="457200"/>
+          </a:xfrm>
+          <a:prstGeom prst="rect">
+            <a:avLst/>
+          </a:prstGeom>
+        </p:spPr>
+        <p:txBody>
+          <a:bodyPr vert="horz" lIns="91440" tIns="45720" rIns="91440" bIns="45720" rtlCol="0" anchor="b"/>
+          <a:lstStyle>
+            <a:lvl1pPr algn="l">
+              <a:defRPr sz="1200"/>
+            </a:lvl1pPr>
+          </a:lstStyle>
+          <a:p>
+            <a:endParaRPr lang="en-US"/>
+          </a:p>
+        </p:txBody>
+      </p:sp>
+      <p:sp>
+        <p:nvSpPr>
+          <p:cNvPr id="7" name="Slide Number Placeholder 6"/>
+          <p:cNvSpPr>
+            <a:spLocks noGrp="1"/>
+          </p:cNvSpPr>
+          <p:nvPr>
+            <p:ph type="sldNum" sz="quarter" idx="5"/>
+          </p:nvPr>
+        </p:nvSpPr>
+        <p:spPr>
+          <a:xfrm>
+            <a:off x="3884613" y="8685213"/>
+            <a:ext cx="2971800" cy="457200"/>
+          </a:xfrm>
+          <a:prstGeom prst="rect">
+            <a:avLst/>
+          </a:prstGeom>
+        </p:spPr>
+        <p:txBody>
+          <a:bodyPr vert="horz" lIns="91440" tIns="45720" rIns="91440" bIns="45720" rtlCol="0" anchor="b"/>
+          <a:lstStyle>
+            <a:lvl1pPr algn="r">
+              <a:defRPr sz="1200"/>
+            </a:lvl1pPr>
+          </a:lstStyle>
+          <a:p>
+            <a:fld id="{BB5E49A5-4136-284D-997B-48E1D791AD67}" type="slidenum">
+              <a:rPr lang="en-US" smtClean="0"/>
+              <a:t>‹#›</a:t>
+            </a:fld>
+            <a:endParaRPr lang="en-US"/>
+          </a:p>
+        </p:txBody>
+      </p:sp>
+    </p:spTree>
+    <p:extLst>
+      <p:ext uri="{BB962C8B-B14F-4D97-AF65-F5344CB8AC3E}">
+        <p14:creationId xmlns:p14="http://schemas.microsoft.com/office/powerpoint/2010/main" val="2623252185"/>
+      </p:ext>
+    </p:extLst>
+  </p:cSld>
+  <p:clrMap bg1="lt1" tx1="dk1" bg2="lt2" tx2="dk2" accent1="accent1" accent2="accent2" accent3="accent3" accent4="accent4" accent5="accent5" accent6="accent6" hlink="hlink" folHlink="folHlink"/>
+  <p:notesStyle>
+    <a:lvl1pPr marL="0" algn="l" defTabSz="457200" rtl="0" eaLnBrk="1" latinLnBrk="0" hangingPunct="1">
+      <a:defRPr sz="1200" kern="1200">
+        <a:solidFill>
+          <a:schemeClr val="tx1"/>
+        </a:solidFill>
+        <a:latin typeface="+mn-lt"/>
+        <a:ea typeface="+mn-ea"/>
+        <a:cs typeface="+mn-cs"/>
+      </a:defRPr>
+    </a:lvl1pPr>
+    <a:lvl2pPr marL="457200" algn="l" defTabSz="457200" rtl="0" eaLnBrk="1" latinLnBrk="0" hangingPunct="1">
+      <a:defRPr sz="1200" kern="1200">
+        <a:solidFill>
+          <a:schemeClr val="tx1"/>
+        </a:solidFill>
+        <a:latin typeface="+mn-lt"/>
+        <a:ea typeface="+mn-ea"/>
+        <a:cs typeface="+mn-cs"/>
+      </a:defRPr>
+    </a:lvl2pPr>
+    <a:lvl3pPr marL="914400" algn="l" defTabSz="457200" rtl="0" eaLnBrk="1" latinLnBrk="0" hangingPunct="1">
+      <a:defRPr sz="1200" kern="1200">
+        <a:solidFill>
+          <a:schemeClr val="tx1"/>
+        </a:solidFill>
+        <a:latin typeface="+mn-lt"/>
+        <a:ea typeface="+mn-ea"/>
+        <a:cs typeface="+mn-cs"/>
+      </a:defRPr>
+    </a:lvl3pPr>
+    <a:lvl4pPr marL="1371600" algn="l" defTabSz="457200" rtl="0" eaLnBrk="1" latinLnBrk="0" hangingPunct="1">
+      <a:defRPr sz="1200" kern="1200">
+        <a:solidFill>
+          <a:schemeClr val="tx1"/>
+        </a:solidFill>
+        <a:latin typeface="+mn-lt"/>
+        <a:ea typeface="+mn-ea"/>
+        <a:cs typeface="+mn-cs"/>
+      </a:defRPr>
+    </a:lvl4pPr>
+    <a:lvl5pPr marL="1828800" algn="l" defTabSz="457200" rtl="0" eaLnBrk="1" latinLnBrk="0" hangingPunct="1">
+      <a:defRPr sz="1200" kern="1200">
+        <a:solidFill>
+          <a:schemeClr val="tx1"/>
+        </a:solidFill>
+        <a:latin typeface="+mn-lt"/>
+        <a:ea typeface="+mn-ea"/>
+        <a:cs typeface="+mn-cs"/>
+      </a:defRPr>
+    </a:lvl5pPr>
+    <a:lvl6pPr marL="2286000" algn="l" defTabSz="457200" rtl="0" eaLnBrk="1" latinLnBrk="0" hangingPunct="1">
+      <a:defRPr sz="1200" kern="1200">
+        <a:solidFill>
+          <a:schemeClr val="tx1"/>
+        </a:solidFill>
+        <a:latin typeface="+mn-lt"/>
+        <a:ea typeface="+mn-ea"/>
+        <a:cs typeface="+mn-cs"/>
+      </a:defRPr>
+    </a:lvl6pPr>
+    <a:lvl7pPr marL="2743200" algn="l" defTabSz="457200" rtl="0" eaLnBrk="1" latinLnBrk="0" hangingPunct="1">
+      <a:defRPr sz="1200" kern="1200">
+        <a:solidFill>
+          <a:schemeClr val="tx1"/>
+        </a:solidFill>
+        <a:latin typeface="+mn-lt"/>
+        <a:ea typeface="+mn-ea"/>
+        <a:cs typeface="+mn-cs"/>
+      </a:defRPr>
+    </a:lvl7pPr>
+    <a:lvl8pPr marL="3200400" algn="l" defTabSz="457200" rtl="0" eaLnBrk="1" latinLnBrk="0" hangingPunct="1">
+      <a:defRPr sz="1200" kern="1200">
+        <a:solidFill>
+          <a:schemeClr val="tx1"/>
+        </a:solidFill>
+        <a:latin typeface="+mn-lt"/>
+        <a:ea typeface="+mn-ea"/>
+        <a:cs typeface="+mn-cs"/>
+      </a:defRPr>
+    </a:lvl8pPr>
+    <a:lvl9pPr marL="3657600" algn="l" defTabSz="457200" rtl="0" eaLnBrk="1" latinLnBrk="0" hangingPunct="1">
+      <a:defRPr sz="1200" kern="1200">
+        <a:solidFill>
+          <a:schemeClr val="tx1"/>
+        </a:solidFill>
+        <a:latin typeface="+mn-lt"/>
+        <a:ea typeface="+mn-ea"/>
+        <a:cs typeface="+mn-cs"/>
+      </a:defRPr>
+    </a:lvl9pPr>
+  </p:notesStyle>
+</p:notesMaster>
+</file>
+
+<file path=ppt/notesSlides/notesSlide1.xml><?xml version="1.0" encoding="utf-8"?>
+<p:notes xmlns:a="http://schemas.openxmlformats.org/drawingml/2006/main" xmlns:p="http://schemas.openxmlformats.org/presentationml/2006/main" xmlns:r="http://schemas.openxmlformats.org/officeDocument/2006/relationships">
+  <p:cSld>
+    <p:spTree>
+      <p:nvGrpSpPr>
+        <p:cNvPr id="1" name=""/>
+        <p:cNvGrpSpPr/>
+        <p:nvPr/>
+      </p:nvGrpSpPr>
+      <p:grpSpPr>
+        <a:xfrm>
+          <a:off x="0" y="0"/>
+          <a:ext cx="0" cy="0"/>
+          <a:chOff x="0" y="0"/>
+          <a:chExt cx="0" cy="0"/>
+        </a:xfrm>
+      </p:grpSpPr>
+      <p:sp>
+        <p:nvSpPr>
+          <p:cNvPr id="2" name="Slide Image Placeholder 1"/>
+          <p:cNvSpPr>
+            <a:spLocks noGrp="1"/>
+          </p:cNvSpPr>
+          <p:nvPr>
+            <p:ph type="sldImg" idx="2"/>
+          </p:nvPr>
+        </p:nvSpPr>
+        <p:spPr/>
+      </p:sp>
+      <p:sp>
+        <p:nvSpPr>
+          <p:cNvPr id="3" name="Notes Placeholder 2"/>
+          <p:cNvSpPr>
+            <a:spLocks noGrp="1"/>
+          </p:cNvSpPr>
+          <p:nvPr>
+            <p:ph type="body" idx="3" sz="quarter"/>
+          </p:nvPr>
+        </p:nvSpPr>
+        <p:spPr/>
+        <p:txBody>
+          <a:bodyPr/>
+          <a:lstStyle/>
+          <a:p>
+            <a:r>
+              <a:t>INTERNALS (for presenter):</a:t>
+            </a:r>
+          </a:p>
+          <a:p>
+            <a:r>
+              <a:t>• Tuples are immutable: once created, you cannot add/remove/change elements. Python can optimize storage and reuse.</a:t>
+            </a:r>
+          </a:p>
+          <a:p>
+            <a:r>
+              <a:t>• Stored as a fixed-size sequence in memory; indexing by position is O(1).</a:t>
+            </a:r>
+          </a:p>
+          <a:p>
+            <a:r>
+              <a:t>• Tuples are hashable if all elements are hashable — so they can be used as dict keys or set elements (e.g. (scheme_id, year)).</a:t>
+            </a:r>
+          </a:p>
+          <a:p>
+            <a:r>
+              <a:t>• Less memory overhead than lists when the sequence never changes.</a:t>
+            </a:r>
+          </a:p>
+        </p:txBody>
+      </p:sp>
+      <p:sp>
+        <p:nvSpPr>
+          <p:cNvPr id="4" name="Slide Number Placeholder 3"/>
+          <p:cNvSpPr>
+            <a:spLocks noGrp="1"/>
+          </p:cNvSpPr>
+          <p:nvPr>
+            <p:ph type="sldNum" idx="5" sz="quarter"/>
+          </p:nvPr>
+        </p:nvSpPr>
+        <p:spPr/>
+      </p:sp>
+    </p:spTree>
+  </p:cSld>
+  <p:clrMapOvr>
+    <a:masterClrMapping/>
+  </p:clrMapOvr>
+</p:notes>
+</file>
+
+<file path=ppt/notesSlides/notesSlide2.xml><?xml version="1.0" encoding="utf-8"?>
+<p:notes xmlns:a="http://schemas.openxmlformats.org/drawingml/2006/main" xmlns:p="http://schemas.openxmlformats.org/presentationml/2006/main" xmlns:r="http://schemas.openxmlformats.org/officeDocument/2006/relationships">
+  <p:cSld>
+    <p:spTree>
+      <p:nvGrpSpPr>
+        <p:cNvPr id="1" name=""/>
+        <p:cNvGrpSpPr/>
+        <p:nvPr/>
+      </p:nvGrpSpPr>
+      <p:grpSpPr>
+        <a:xfrm>
+          <a:off x="0" y="0"/>
+          <a:ext cx="0" cy="0"/>
+          <a:chOff x="0" y="0"/>
+          <a:chExt cx="0" cy="0"/>
+        </a:xfrm>
+      </p:grpSpPr>
+      <p:sp>
+        <p:nvSpPr>
+          <p:cNvPr id="2" name="Slide Image Placeholder 1"/>
+          <p:cNvSpPr>
+            <a:spLocks noGrp="1"/>
+          </p:cNvSpPr>
+          <p:nvPr>
+            <p:ph type="sldImg" idx="2"/>
+          </p:nvPr>
+        </p:nvSpPr>
+        <p:spPr/>
+      </p:sp>
+      <p:sp>
+        <p:nvSpPr>
+          <p:cNvPr id="3" name="Notes Placeholder 2"/>
+          <p:cNvSpPr>
+            <a:spLocks noGrp="1"/>
+          </p:cNvSpPr>
+          <p:nvPr>
+            <p:ph type="body" idx="3" sz="quarter"/>
+          </p:nvPr>
+        </p:nvSpPr>
+        <p:spPr/>
+        <p:txBody>
+          <a:bodyPr/>
+          <a:lstStyle/>
+          <a:p>
+            <a:r>
+              <a:t>INTERNALS (for presenter):</a:t>
+            </a:r>
+          </a:p>
+          <a:p>
+            <a:r>
+              <a:t>• Sets are implemented with a hash table: each element must be hashable (no lists/dicts inside the set).</a:t>
+            </a:r>
+          </a:p>
+          <a:p>
+            <a:r>
+              <a:t>• Membership check (x in s) is O(1) on average — very fast for large collections.</a:t>
+            </a:r>
+          </a:p>
+          <a:p>
+            <a:r>
+              <a:t>• Order is not guaranteed; Python may reorder for efficiency. Do not rely on order.</a:t>
+            </a:r>
+          </a:p>
+          <a:p>
+            <a:r>
+              <a:t>• Adding/removing is O(1) average. Union, intersection, difference are efficient.</a:t>
+            </a:r>
+          </a:p>
+        </p:txBody>
+      </p:sp>
+      <p:sp>
+        <p:nvSpPr>
+          <p:cNvPr id="4" name="Slide Number Placeholder 3"/>
+          <p:cNvSpPr>
+            <a:spLocks noGrp="1"/>
+          </p:cNvSpPr>
+          <p:nvPr>
+            <p:ph type="sldNum" idx="5" sz="quarter"/>
+          </p:nvPr>
+        </p:nvSpPr>
+        <p:spPr/>
+      </p:sp>
+    </p:spTree>
+  </p:cSld>
+  <p:clrMapOvr>
+    <a:masterClrMapping/>
+  </p:clrMapOvr>
+</p:notes>
+</file>
+
+<file path=ppt/notesSlides/notesSlide3.xml><?xml version="1.0" encoding="utf-8"?>
+<p:notes xmlns:a="http://schemas.openxmlformats.org/drawingml/2006/main" xmlns:p="http://schemas.openxmlformats.org/presentationml/2006/main" xmlns:r="http://schemas.openxmlformats.org/officeDocument/2006/relationships">
+  <p:cSld>
+    <p:spTree>
+      <p:nvGrpSpPr>
+        <p:cNvPr id="1" name=""/>
+        <p:cNvGrpSpPr/>
+        <p:nvPr/>
+      </p:nvGrpSpPr>
+      <p:grpSpPr>
+        <a:xfrm>
+          <a:off x="0" y="0"/>
+          <a:ext cx="0" cy="0"/>
+          <a:chOff x="0" y="0"/>
+          <a:chExt cx="0" cy="0"/>
+        </a:xfrm>
+      </p:grpSpPr>
+      <p:sp>
+        <p:nvSpPr>
+          <p:cNvPr id="2" name="Slide Image Placeholder 1"/>
+          <p:cNvSpPr>
+            <a:spLocks noGrp="1"/>
+          </p:cNvSpPr>
+          <p:nvPr>
+            <p:ph type="sldImg" idx="2"/>
+          </p:nvPr>
+        </p:nvSpPr>
+        <p:spPr/>
+      </p:sp>
+      <p:sp>
+        <p:nvSpPr>
+          <p:cNvPr id="3" name="Notes Placeholder 2"/>
+          <p:cNvSpPr>
+            <a:spLocks noGrp="1"/>
+          </p:cNvSpPr>
+          <p:nvPr>
+            <p:ph type="body" idx="3" sz="quarter"/>
+          </p:nvPr>
+        </p:nvSpPr>
+        <p:spPr/>
+        <p:txBody>
+          <a:bodyPr/>
+          <a:lstStyle/>
+          <a:p>
+            <a:r>
+              <a:t>INTERNALS (for presenter):</a:t>
+            </a:r>
+          </a:p>
+          <a:p>
+            <a:r>
+              <a:t>• Dicts are implemented with a hash table: keys must be hashable (e.g. str, int, tuple of hashables).</a:t>
+            </a:r>
+          </a:p>
+          <a:p>
+            <a:r>
+              <a:t>• Lookup by key (d[key]) is O(1) on average — ideal for scheme_id → details.</a:t>
+            </a:r>
+          </a:p>
+          <a:p>
+            <a:r>
+              <a:t>• Insertion and deletion by key are also O(1) average.</a:t>
+            </a:r>
+          </a:p>
+          <a:p>
+            <a:r>
+              <a:t>• From Python 3.7+ dicts preserve insertion order; iterating is in the order keys were added.</a:t>
+            </a:r>
+          </a:p>
+        </p:txBody>
+      </p:sp>
+      <p:sp>
+        <p:nvSpPr>
+          <p:cNvPr id="4" name="Slide Number Placeholder 3"/>
+          <p:cNvSpPr>
+            <a:spLocks noGrp="1"/>
+          </p:cNvSpPr>
+          <p:nvPr>
+            <p:ph type="sldNum" idx="5" sz="quarter"/>
+          </p:nvPr>
+        </p:nvSpPr>
+        <p:spPr/>
+      </p:sp>
+    </p:spTree>
+  </p:cSld>
+  <p:clrMapOvr>
+    <a:masterClrMapping/>
+  </p:clrMapOvr>
+</p:notes>
+</file>
+
+<file path=ppt/notesSlides/notesSlide4.xml><?xml version="1.0" encoding="utf-8"?>
+<p:notes xmlns:a="http://schemas.openxmlformats.org/drawingml/2006/main" xmlns:p="http://schemas.openxmlformats.org/presentationml/2006/main" xmlns:r="http://schemas.openxmlformats.org/officeDocument/2006/relationships">
+  <p:cSld>
+    <p:spTree>
+      <p:nvGrpSpPr>
+        <p:cNvPr id="1" name=""/>
+        <p:cNvGrpSpPr/>
+        <p:nvPr/>
+      </p:nvGrpSpPr>
+      <p:grpSpPr>
+        <a:xfrm>
+          <a:off x="0" y="0"/>
+          <a:ext cx="0" cy="0"/>
+          <a:chOff x="0" y="0"/>
+          <a:chExt cx="0" cy="0"/>
+        </a:xfrm>
+      </p:grpSpPr>
+      <p:sp>
+        <p:nvSpPr>
+          <p:cNvPr id="2" name="Slide Image Placeholder 1"/>
+          <p:cNvSpPr>
+            <a:spLocks noGrp="1"/>
+          </p:cNvSpPr>
+          <p:nvPr>
+            <p:ph type="sldImg" idx="2"/>
+          </p:nvPr>
+        </p:nvSpPr>
+        <p:spPr/>
+      </p:sp>
+      <p:sp>
+        <p:nvSpPr>
+          <p:cNvPr id="3" name="Notes Placeholder 2"/>
+          <p:cNvSpPr>
+            <a:spLocks noGrp="1"/>
+          </p:cNvSpPr>
+          <p:nvPr>
+            <p:ph type="body" idx="3" sz="quarter"/>
+          </p:nvPr>
+        </p:nvSpPr>
+        <p:spPr/>
+        <p:txBody>
+          <a:bodyPr/>
+          <a:lstStyle/>
+          <a:p>
+            <a:r>
+              <a:t>Use this slide + notes to explain internals when students ask "why is set/dict fast?" or "why can't I put a list in a set?".</a:t>
+            </a:r>
+          </a:p>
+          <a:p/>
+          <a:p>
+            <a:r>
+              <a:t>TUPLES: Immutability allows Python to optimize; no reallocation. Hashable tuples can go in sets/dict keys.</a:t>
+            </a:r>
+          </a:p>
+          <a:p/>
+          <a:p>
+            <a:r>
+              <a:t>SETS: Hash table gives O(1) 'in' check. Uniqueness is enforced by hash + equality. So only hashable types allowed.</a:t>
+            </a:r>
+          </a:p>
+          <a:p/>
+          <a:p>
+            <a:r>
+              <a:t>DICTIONARIES: Same idea — hash(key) determines bucket; O(1) average for get/set/del. .get(key, default) avoids KeyError.</a:t>
+            </a:r>
+          </a:p>
+        </p:txBody>
+      </p:sp>
+      <p:sp>
+        <p:nvSpPr>
+          <p:cNvPr id="4" name="Slide Number Placeholder 3"/>
+          <p:cNvSpPr>
+            <a:spLocks noGrp="1"/>
+          </p:cNvSpPr>
+          <p:nvPr>
+            <p:ph type="sldNum" idx="5" sz="quarter"/>
+          </p:nvPr>
+        </p:nvSpPr>
+        <p:spPr/>
+      </p:sp>
+    </p:spTree>
+  </p:cSld>
+  <p:clrMapOvr>
+    <a:masterClrMapping/>
+  </p:clrMapOvr>
+</p:notes>
 </file>
 
 <file path=ppt/slideLayouts/slideLayout1.xml><?xml version="1.0" encoding="utf-8"?>
@@ -3146,6 +3855,92 @@
 </p:sld>
 </file>
 
+<file path=ppt/slides/slide10.xml><?xml version="1.0" encoding="utf-8"?>
+<p:sld xmlns:a="http://schemas.openxmlformats.org/drawingml/2006/main" xmlns:p="http://schemas.openxmlformats.org/presentationml/2006/main" xmlns:r="http://schemas.openxmlformats.org/officeDocument/2006/relationships">
+  <p:cSld>
+    <p:spTree>
+      <p:nvGrpSpPr>
+        <p:cNvPr id="1" name=""/>
+        <p:cNvGrpSpPr/>
+        <p:nvPr/>
+      </p:nvGrpSpPr>
+      <p:grpSpPr/>
+      <p:sp>
+        <p:nvSpPr>
+          <p:cNvPr id="2" name="Title 1"/>
+          <p:cNvSpPr>
+            <a:spLocks noGrp="1"/>
+          </p:cNvSpPr>
+          <p:nvPr>
+            <p:ph type="title"/>
+          </p:nvPr>
+        </p:nvSpPr>
+        <p:spPr/>
+        <p:txBody>
+          <a:bodyPr/>
+          <a:lstStyle/>
+          <a:p>
+            <a:r>
+              <a:t>References</a:t>
+            </a:r>
+          </a:p>
+        </p:txBody>
+      </p:sp>
+      <p:sp>
+        <p:nvSpPr>
+          <p:cNvPr id="3" name="Content Placeholder 2"/>
+          <p:cNvSpPr>
+            <a:spLocks noGrp="1"/>
+          </p:cNvSpPr>
+          <p:nvPr>
+            <p:ph idx="1"/>
+          </p:nvPr>
+        </p:nvSpPr>
+        <p:spPr/>
+        <p:txBody>
+          <a:bodyPr/>
+          <a:lstStyle/>
+          <a:p/>
+          <a:p>
+            <a:pPr/>
+            <a:r>
+              <a:t>Downey, A. (2012). Think Python. O'Reilly Media, Inc.</a:t>
+            </a:r>
+          </a:p>
+          <a:p>
+            <a:pPr/>
+            <a:r>
+              <a:t>Matthes, E. (2023). Python Crash Course: A hands-on, project-based introduction to programming.</a:t>
+            </a:r>
+          </a:p>
+          <a:p>
+            <a:pPr/>
+            <a:r>
+              <a:t>Müller, A. C., &amp; Guido, S. (2016). Introduction to machine learning with Python: a guide for data scientists. O'Reilly Media, Inc.</a:t>
+            </a:r>
+          </a:p>
+          <a:p>
+            <a:pPr/>
+            <a:r>
+              <a:t>GeeksforGeeks Python: https://www.geeksforgeeks.org/python/</a:t>
+            </a:r>
+          </a:p>
+          <a:p>
+            <a:pPr/>
+            <a:r>
+              <a:t>W3Schools Python: https://www.w3schools.com/python/</a:t>
+            </a:r>
+          </a:p>
+        </p:txBody>
+      </p:sp>
+    </p:spTree>
+  </p:cSld>
+  <p:clrMapOvr>
+    <a:masterClrMapping/>
+  </p:clrMapOvr>
+</p:sld>
+</file>
+
 <file path=ppt/slides/slide2.xml><?xml version="1.0" encoding="utf-8"?>
 <p:sld xmlns:a="http://schemas.openxmlformats.org/drawingml/2006/main" xmlns:p="http://schemas.openxmlformats.org/presentationml/2006/main" xmlns:r="http://schemas.openxmlformats.org/officeDocument/2006/relationships">
   <p:cSld>
@@ -3468,7 +4263,7 @@
           <a:lstStyle/>
           <a:p>
             <a:r>
-              <a:t>When to use which? (management &amp; policy)</a:t>
+              <a:t>Under the hood: Tuples, Sets, Dictionaries</a:t>
             </a:r>
           </a:p>
         </p:txBody>
@@ -3491,19 +4286,19 @@
           <a:p>
             <a:pPr/>
             <a:r>
-              <a:t>Tuple: one fixed record (e.g. scheme name, financial year, allocated amount).</a:t>
+              <a:t>Tuple: immutable, fixed sequence; hashable if elements are hashable; O(1) index access.</a:t>
             </a:r>
           </a:p>
           <a:p>
             <a:pPr/>
             <a:r>
-              <a:t>Set: unique beneficiaries, unique districts in a program, unique response categories.</a:t>
+              <a:t>Set: hash table; O(1) membership; elements must be hashable; order not guaranteed.</a:t>
             </a:r>
           </a:p>
           <a:p>
             <a:pPr/>
             <a:r>
-              <a:t>Dict: scheme_id → full details; department → contact; indicator_code → definition.</a:t>
+              <a:t>Dict: hash table; O(1) lookup by key; keys must be hashable; insertion order preserved (3.7+).</a:t>
             </a:r>
           </a:p>
         </p:txBody>
@@ -3542,7 +4337,7 @@
           <a:lstStyle/>
           <a:p>
             <a:r>
-              <a:t>Practical in-class (Colab)</a:t>
+              <a:t>When to use which? (management &amp; policy)</a:t>
             </a:r>
           </a:p>
         </p:txBody>
@@ -3565,19 +4360,19 @@
           <a:p>
             <a:pPr/>
             <a:r>
-              <a:t>Session 8 Student notebook: tuples (policy record), sets (unique regions/beneficiaries), dicts (scheme lookup).</a:t>
+              <a:t>Tuple: one fixed record (e.g. scheme name, financial year, allocated amount).</a:t>
             </a:r>
           </a:p>
           <a:p>
             <a:pPr/>
             <a:r>
-              <a:t>Hands-on: e.g. count unique districts in a program, build a scheme lookup table.</a:t>
+              <a:t>Set: unique beneficiaries, unique districts in a program, unique response categories.</a:t>
             </a:r>
           </a:p>
           <a:p>
             <a:pPr/>
             <a:r>
-              <a:t>All examples use business management and public policy contexts.</a:t>
+              <a:t>Dict: scheme_id → full details; department → contact; indicator_code → definition.</a:t>
             </a:r>
           </a:p>
         </p:txBody>
@@ -3616,7 +4411,7 @@
           <a:lstStyle/>
           <a:p>
             <a:r>
-              <a:t>Session 8 – Recap</a:t>
+              <a:t>Practical in-class (Colab)</a:t>
             </a:r>
           </a:p>
         </p:txBody>
@@ -3639,19 +4434,19 @@
           <a:p>
             <a:pPr/>
             <a:r>
-              <a:t>Tuples: immutable, ordered.</a:t>
+              <a:t>Session 8 Student notebook: tuples (policy record), sets (unique regions/beneficiaries), dicts (scheme lookup).</a:t>
             </a:r>
           </a:p>
           <a:p>
             <a:pPr/>
             <a:r>
-              <a:t>Sets: unique, unordered, fast membership.</a:t>
+              <a:t>Hands-on: e.g. count unique districts in a program, build a scheme lookup table.</a:t>
             </a:r>
           </a:p>
           <a:p>
             <a:pPr/>
             <a:r>
-              <a:t>Dictionaries: key–value, fast lookup by key.</a:t>
+              <a:t>All examples use business management and public policy contexts.</a:t>
             </a:r>
           </a:p>
         </p:txBody>
@@ -3690,7 +4485,7 @@
           <a:lstStyle/>
           <a:p>
             <a:r>
-              <a:t>References</a:t>
+              <a:t>Session 8 – Recap</a:t>
             </a:r>
           </a:p>
         </p:txBody>
@@ -3713,31 +4508,19 @@
           <a:p>
             <a:pPr/>
             <a:r>
-              <a:t>Downey, A. (2012). Think Python. O'Reilly Media, Inc.</a:t>
+              <a:t>Tuples: immutable, ordered.</a:t>
             </a:r>
           </a:p>
           <a:p>
             <a:pPr/>
             <a:r>
-              <a:t>Matthes, E. (2023). Python Crash Course: A hands-on, project-based introduction to programming.</a:t>
+              <a:t>Sets: unique, unordered, fast membership.</a:t>
             </a:r>
           </a:p>
           <a:p>
             <a:pPr/>
             <a:r>
-              <a:t>Müller, A. C., &amp; Guido, S. (2016). Introduction to machine learning with Python: a guide for data scientists. O'Reilly Media, Inc.</a:t>
-            </a:r>
-          </a:p>
-          <a:p>
-            <a:pPr/>
-            <a:r>
-              <a:t>GeeksforGeeks Python: https://www.geeksforgeeks.org/python/</a:t>
-            </a:r>
-          </a:p>
-          <a:p>
-            <a:pPr/>
-            <a:r>
-              <a:t>W3Schools Python: https://www.w3schools.com/python/</a:t>
+              <a:t>Dictionaries: key–value, fast lookup by key.</a:t>
             </a:r>
           </a:p>
         </p:txBody>
@@ -4068,4 +4851,324 @@
   </a:objectDefaults>
   <a:extraClrSchemeLst/>
 </a:theme>
+</file>
+
+<file path=ppt/theme/theme2.xml><?xml version="1.0" encoding="utf-8"?>
+<a:theme xmlns:a="http://schemas.openxmlformats.org/drawingml/2006/main" name="Office Theme">
+  <a:themeElements>
+    <a:clrScheme name="Office">
+      <a:dk1>
+        <a:sysClr val="windowText" lastClr="000000"/>
+      </a:dk1>
+      <a:lt1>
+        <a:sysClr val="window" lastClr="FFFFFF"/>
+      </a:lt1>
+      <a:dk2>
+        <a:srgbClr val="1F497D"/>
+      </a:dk2>
+      <a:lt2>
+        <a:srgbClr val="EEECE1"/>
+      </a:lt2>
+      <a:accent1>
+        <a:srgbClr val="4F81BD"/>
+      </a:accent1>
+      <a:accent2>
+        <a:srgbClr val="C0504D"/>
+      </a:accent2>
+      <a:accent3>
+        <a:srgbClr val="9BBB59"/>
+      </a:accent3>
+      <a:accent4>
+        <a:srgbClr val="8064A2"/>
+      </a:accent4>
+      <a:accent5>
+        <a:srgbClr val="4BACC6"/>
+      </a:accent5>
+      <a:accent6>
+        <a:srgbClr val="F79646"/>
+      </a:accent6>
+      <a:hlink>
+        <a:srgbClr val="0000FF"/>
+      </a:hlink>
+      <a:folHlink>
+        <a:srgbClr val="800080"/>
+      </a:folHlink>
+    </a:clrScheme>
+    <a:fontScheme name="Office">
+      <a:majorFont>
+        <a:latin typeface="Calibri"/>
+        <a:ea typeface=""/>
+        <a:cs typeface=""/>
+        <a:font script="Jpan" typeface="ＭＳ Ｐゴシック"/>
+        <a:font script="Hang" typeface="맑은 고딕"/>
+        <a:font script="Hans" typeface="宋体"/>
+        <a:font script="Hant" typeface="新細明體"/>
+        <a:font script="Arab" typeface="Times New Roman"/>
+        <a:font script="Hebr" typeface="Times New Roman"/>
+        <a:font script="Thai" typeface="Angsana New"/>
+        <a:font script="Ethi" typeface="Nyala"/>
+        <a:font script="Beng" typeface="Vrinda"/>
+        <a:font script="Gujr" typeface="Shruti"/>
+        <a:font script="Khmr" typeface="MoolBoran"/>
+        <a:font script="Knda" typeface="Tunga"/>
+        <a:font script="Guru" typeface="Raavi"/>
+        <a:font script="Cans" typeface="Euphemia"/>
+        <a:font script="Cher" typeface="Plantagenet Cherokee"/>
+        <a:font script="Yiii" typeface="Microsoft Yi Baiti"/>
+        <a:font script="Tibt" typeface="Microsoft Himalaya"/>
+        <a:font script="Thaa" typeface="MV Boli"/>
+        <a:font script="Deva" typeface="Mangal"/>
+        <a:font script="Telu" typeface="Gautami"/>
+        <a:font script="Taml" typeface="Latha"/>
+        <a:font script="Syrc" typeface="Estrangelo Edessa"/>
+        <a:font script="Orya" typeface="Kalinga"/>
+        <a:font script="Mlym" typeface="Kartika"/>
+        <a:font script="Laoo" typeface="DokChampa"/>
+        <a:font script="Sinh" typeface="Iskoola Pota"/>
+        <a:font script="Mong" typeface="Mongolian Baiti"/>
+        <a:font script="Viet" typeface="Times New Roman"/>
+        <a:font script="Uigh" typeface="Microsoft Uighur"/>
+        <a:font script="Geor" typeface="Sylfaen"/>
+      </a:majorFont>
+      <a:minorFont>
+        <a:latin typeface="Calibri"/>
+        <a:ea typeface=""/>
+        <a:cs typeface=""/>
+        <a:font script="Jpan" typeface="ＭＳ Ｐゴシック"/>
+        <a:font script="Hang" typeface="맑은 고딕"/>
+        <a:font script="Hans" typeface="宋体"/>
+        <a:font script="Hant" typeface="新細明體"/>
+        <a:font script="Arab" typeface="Arial"/>
+        <a:font script="Hebr" typeface="Arial"/>
+        <a:font script="Thai" typeface="Cordia New"/>
+        <a:font script="Ethi" typeface="Nyala"/>
+        <a:font script="Beng" typeface="Vrinda"/>
+        <a:font script="Gujr" typeface="Shruti"/>
+        <a:font script="Khmr" typeface="DaunPenh"/>
+        <a:font script="Knda" typeface="Tunga"/>
+        <a:font script="Guru" typeface="Raavi"/>
+        <a:font script="Cans" typeface="Euphemia"/>
+        <a:font script="Cher" typeface="Plantagenet Cherokee"/>
+        <a:font script="Yiii" typeface="Microsoft Yi Baiti"/>
+        <a:font script="Tibt" typeface="Microsoft Himalaya"/>
+        <a:font script="Thaa" typeface="MV Boli"/>
+        <a:font script="Deva" typeface="Mangal"/>
+        <a:font script="Telu" typeface="Gautami"/>
+        <a:font script="Taml" typeface="Latha"/>
+        <a:font script="Syrc" typeface="Estrangelo Edessa"/>
+        <a:font script="Orya" typeface="Kalinga"/>
+        <a:font script="Mlym" typeface="Kartika"/>
+        <a:font script="Laoo" typeface="DokChampa"/>
+        <a:font script="Sinh" typeface="Iskoola Pota"/>
+        <a:font script="Mong" typeface="Mongolian Baiti"/>
+        <a:font script="Viet" typeface="Arial"/>
+        <a:font script="Uigh" typeface="Microsoft Uighur"/>
+        <a:font script="Geor" typeface="Sylfaen"/>
+      </a:minorFont>
+    </a:fontScheme>
+    <a:fmtScheme name="Office">
+      <a:fillStyleLst>
+        <a:solidFill>
+          <a:schemeClr val="phClr"/>
+        </a:solidFill>
+        <a:gradFill rotWithShape="1">
+          <a:gsLst>
+            <a:gs pos="0">
+              <a:schemeClr val="phClr">
+                <a:tint val="50000"/>
+                <a:satMod val="300000"/>
+              </a:schemeClr>
+            </a:gs>
+            <a:gs pos="35000">
+              <a:schemeClr val="phClr">
+                <a:tint val="37000"/>
+                <a:satMod val="300000"/>
+              </a:schemeClr>
+            </a:gs>
+            <a:gs pos="100000">
+              <a:schemeClr val="phClr">
+                <a:tint val="15000"/>
+                <a:satMod val="350000"/>
+              </a:schemeClr>
+            </a:gs>
+          </a:gsLst>
+          <a:lin ang="16200000" scaled="1"/>
+        </a:gradFill>
+        <a:gradFill rotWithShape="1">
+          <a:gsLst>
+            <a:gs pos="0">
+              <a:schemeClr val="phClr">
+                <a:tint val="100000"/>
+                <a:shade val="100000"/>
+                <a:satMod val="130000"/>
+              </a:schemeClr>
+            </a:gs>
+            <a:gs pos="100000">
+              <a:schemeClr val="phClr">
+                <a:tint val="50000"/>
+                <a:shade val="100000"/>
+                <a:satMod val="350000"/>
+              </a:schemeClr>
+            </a:gs>
+          </a:gsLst>
+          <a:lin ang="16200000" scaled="0"/>
+        </a:gradFill>
+      </a:fillStyleLst>
+      <a:lnStyleLst>
+        <a:ln w="9525" cap="flat" cmpd="sng" algn="ctr">
+          <a:solidFill>
+            <a:schemeClr val="phClr">
+              <a:shade val="95000"/>
+              <a:satMod val="105000"/>
+            </a:schemeClr>
+          </a:solidFill>
+          <a:prstDash val="solid"/>
+        </a:ln>
+        <a:ln w="25400" cap="flat" cmpd="sng" algn="ctr">
+          <a:solidFill>
+            <a:schemeClr val="phClr"/>
+          </a:solidFill>
+          <a:prstDash val="solid"/>
+        </a:ln>
+        <a:ln w="38100" cap="flat" cmpd="sng" algn="ctr">
+          <a:solidFill>
+            <a:schemeClr val="phClr"/>
+          </a:solidFill>
+          <a:prstDash val="solid"/>
+        </a:ln>
+      </a:lnStyleLst>
+      <a:effectStyleLst>
+        <a:effectStyle>
+          <a:effectLst>
+            <a:outerShdw blurRad="40000" dist="20000" dir="5400000" rotWithShape="0">
+              <a:srgbClr val="000000">
+                <a:alpha val="38000"/>
+              </a:srgbClr>
+            </a:outerShdw>
+          </a:effectLst>
+        </a:effectStyle>
+        <a:effectStyle>
+          <a:effectLst>
+            <a:outerShdw blurRad="40000" dist="23000" dir="5400000" rotWithShape="0">
+              <a:srgbClr val="000000">
+                <a:alpha val="35000"/>
+              </a:srgbClr>
+            </a:outerShdw>
+          </a:effectLst>
+        </a:effectStyle>
+        <a:effectStyle>
+          <a:effectLst>
+            <a:outerShdw blurRad="40000" dist="23000" dir="5400000" rotWithShape="0">
+              <a:srgbClr val="000000">
+                <a:alpha val="35000"/>
+              </a:srgbClr>
+            </a:outerShdw>
+          </a:effectLst>
+          <a:scene3d>
+            <a:camera prst="orthographicFront">
+              <a:rot lat="0" lon="0" rev="0"/>
+            </a:camera>
+            <a:lightRig rig="threePt" dir="t">
+              <a:rot lat="0" lon="0" rev="1200000"/>
+            </a:lightRig>
+          </a:scene3d>
+          <a:sp3d>
+            <a:bevelT w="63500" h="25400"/>
+          </a:sp3d>
+        </a:effectStyle>
+      </a:effectStyleLst>
+      <a:bgFillStyleLst>
+        <a:solidFill>
+          <a:schemeClr val="phClr"/>
+        </a:solidFill>
+        <a:gradFill rotWithShape="1">
+          <a:gsLst>
+            <a:gs pos="0">
+              <a:schemeClr val="phClr">
+                <a:tint val="40000"/>
+                <a:satMod val="350000"/>
+              </a:schemeClr>
+            </a:gs>
+            <a:gs pos="40000">
+              <a:schemeClr val="phClr">
+                <a:tint val="45000"/>
+                <a:shade val="99000"/>
+                <a:satMod val="350000"/>
+              </a:schemeClr>
+            </a:gs>
+            <a:gs pos="100000">
+              <a:schemeClr val="phClr">
+                <a:shade val="20000"/>
+                <a:satMod val="255000"/>
+              </a:schemeClr>
+            </a:gs>
+          </a:gsLst>
+          <a:path path="circle">
+            <a:fillToRect l="50000" t="-80000" r="50000" b="180000"/>
+          </a:path>
+        </a:gradFill>
+        <a:gradFill rotWithShape="1">
+          <a:gsLst>
+            <a:gs pos="0">
+              <a:schemeClr val="phClr">
+                <a:tint val="80000"/>
+                <a:satMod val="300000"/>
+              </a:schemeClr>
+            </a:gs>
+            <a:gs pos="100000">
+              <a:schemeClr val="phClr">
+                <a:shade val="30000"/>
+                <a:satMod val="200000"/>
+              </a:schemeClr>
+            </a:gs>
+          </a:gsLst>
+          <a:path path="circle">
+            <a:fillToRect l="50000" t="50000" r="50000" b="50000"/>
+          </a:path>
+        </a:gradFill>
+      </a:bgFillStyleLst>
+    </a:fmtScheme>
+  </a:themeElements>
+  <a:objectDefaults>
+    <a:spDef>
+      <a:spPr/>
+      <a:bodyPr/>
+      <a:lstStyle/>
+      <a:style>
+        <a:lnRef idx="1">
+          <a:schemeClr val="accent1"/>
+        </a:lnRef>
+        <a:fillRef idx="3">
+          <a:schemeClr val="accent1"/>
+        </a:fillRef>
+        <a:effectRef idx="2">
+          <a:schemeClr val="accent1"/>
+        </a:effectRef>
+        <a:fontRef idx="minor">
+          <a:schemeClr val="lt1"/>
+        </a:fontRef>
+      </a:style>
+    </a:spDef>
+    <a:lnDef>
+      <a:spPr/>
+      <a:bodyPr/>
+      <a:lstStyle/>
+      <a:style>
+        <a:lnRef idx="2">
+          <a:schemeClr val="accent1"/>
+        </a:lnRef>
+        <a:fillRef idx="0">
+          <a:schemeClr val="accent1"/>
+        </a:fillRef>
+        <a:effectRef idx="1">
+          <a:schemeClr val="accent1"/>
+        </a:effectRef>
+        <a:fontRef idx="minor">
+          <a:schemeClr val="tx1"/>
+        </a:fontRef>
+      </a:style>
+    </a:lnDef>
+  </a:objectDefaults>
+  <a:extraClrSchemeLst/>
+</a:theme>
 </file>
</xml_diff>

<commit_message>
Update Session 9 master notebook with executed outputs
</commit_message>
<xml_diff>
--- a/Session8_Tuples_Sets_Dictionaries.pptx
+++ b/Session8_Tuples_Sets_Dictionaries.pptx
@@ -3798,6 +3798,14 @@
 <file path=ppt/slides/slide1.xml><?xml version="1.0" encoding="utf-8"?>
 <p:sld xmlns:a="http://schemas.openxmlformats.org/drawingml/2006/main" xmlns:p="http://schemas.openxmlformats.org/presentationml/2006/main" xmlns:r="http://schemas.openxmlformats.org/officeDocument/2006/relationships">
   <p:cSld>
+    <p:bg>
+      <p:bgPr>
+        <a:solidFill>
+          <a:srgbClr val="F5F8FC"/>
+        </a:solidFill>
+        <a:effectLst/>
+      </p:bgPr>
+    </p:bg>
     <p:spTree>
       <p:nvGrpSpPr>
         <p:cNvPr id="1" name=""/>
@@ -3817,10 +3825,21 @@
         </p:nvSpPr>
         <p:spPr/>
         <p:txBody>
-          <a:bodyPr/>
-          <a:lstStyle/>
-          <a:p>
-            <a:r>
+          <a:bodyPr wrap="square"/>
+          <a:lstStyle/>
+          <a:p>
+            <a:pPr>
+              <a:spcAft>
+                <a:spcPts val="600"/>
+              </a:spcAft>
+            </a:pPr>
+            <a:r>
+              <a:rPr sz="3200" b="1">
+                <a:solidFill>
+                  <a:srgbClr val="15436C"/>
+                </a:solidFill>
+                <a:latin typeface="Calibri"/>
+              </a:rPr>
               <a:t>Session 8: Tuples, Sets &amp; Dictionaries</a:t>
             </a:r>
           </a:p>
@@ -3838,10 +3857,21 @@
         </p:nvSpPr>
         <p:spPr/>
         <p:txBody>
-          <a:bodyPr/>
-          <a:lstStyle/>
-          <a:p>
-            <a:r>
+          <a:bodyPr wrap="square"/>
+          <a:lstStyle/>
+          <a:p>
+            <a:pPr>
+              <a:spcAft>
+                <a:spcPts val="600"/>
+              </a:spcAft>
+            </a:pPr>
+            <a:r>
+              <a:rPr sz="1600" b="0">
+                <a:solidFill>
+                  <a:srgbClr val="465A6E"/>
+                </a:solidFill>
+                <a:latin typeface="Calibri"/>
+              </a:rPr>
               <a:t>FoP – B.S. in Management and Public Policy | 90 min</a:t>
             </a:r>
           </a:p>
@@ -3858,6 +3888,14 @@
 <file path=ppt/slides/slide10.xml><?xml version="1.0" encoding="utf-8"?>
 <p:sld xmlns:a="http://schemas.openxmlformats.org/drawingml/2006/main" xmlns:p="http://schemas.openxmlformats.org/presentationml/2006/main" xmlns:r="http://schemas.openxmlformats.org/officeDocument/2006/relationships">
   <p:cSld>
+    <p:bg>
+      <p:bgPr>
+        <a:solidFill>
+          <a:srgbClr val="F5F8FC"/>
+        </a:solidFill>
+        <a:effectLst/>
+      </p:bgPr>
+    </p:bg>
     <p:spTree>
       <p:nvGrpSpPr>
         <p:cNvPr id="1" name=""/>
@@ -3877,10 +3915,21 @@
         </p:nvSpPr>
         <p:spPr/>
         <p:txBody>
-          <a:bodyPr/>
-          <a:lstStyle/>
-          <a:p>
-            <a:r>
+          <a:bodyPr wrap="square"/>
+          <a:lstStyle/>
+          <a:p>
+            <a:pPr>
+              <a:spcAft>
+                <a:spcPts val="600"/>
+              </a:spcAft>
+            </a:pPr>
+            <a:r>
+              <a:rPr sz="2600" b="1">
+                <a:solidFill>
+                  <a:srgbClr val="15436C"/>
+                </a:solidFill>
+                <a:latin typeface="Calibri"/>
+              </a:rPr>
               <a:t>References</a:t>
             </a:r>
           </a:p>
@@ -3900,34 +3949,83 @@
         <p:txBody>
           <a:bodyPr/>
           <a:lstStyle/>
-          <a:p/>
-          <a:p>
-            <a:pPr/>
-            <a:r>
+          <a:p>
+            <a:pPr>
+              <a:spcAft>
+                <a:spcPts val="800"/>
+              </a:spcAft>
+            </a:pPr>
+            <a:r>
+              <a:rPr sz="1500">
+                <a:solidFill>
+                  <a:srgbClr val="2C2C2E"/>
+                </a:solidFill>
+                <a:latin typeface="Calibri"/>
+              </a:rPr>
               <a:t>Downey, A. (2012). Think Python. O'Reilly Media, Inc.</a:t>
             </a:r>
           </a:p>
           <a:p>
-            <a:pPr/>
-            <a:r>
+            <a:pPr>
+              <a:spcAft>
+                <a:spcPts val="800"/>
+              </a:spcAft>
+            </a:pPr>
+            <a:r>
+              <a:rPr sz="1500">
+                <a:solidFill>
+                  <a:srgbClr val="2C2C2E"/>
+                </a:solidFill>
+                <a:latin typeface="Calibri"/>
+              </a:rPr>
               <a:t>Matthes, E. (2023). Python Crash Course: A hands-on, project-based introduction to programming.</a:t>
             </a:r>
           </a:p>
           <a:p>
-            <a:pPr/>
-            <a:r>
+            <a:pPr>
+              <a:spcAft>
+                <a:spcPts val="800"/>
+              </a:spcAft>
+            </a:pPr>
+            <a:r>
+              <a:rPr sz="1500">
+                <a:solidFill>
+                  <a:srgbClr val="2C2C2E"/>
+                </a:solidFill>
+                <a:latin typeface="Calibri"/>
+              </a:rPr>
               <a:t>Müller, A. C., &amp; Guido, S. (2016). Introduction to machine learning with Python: a guide for data scientists. O'Reilly Media, Inc.</a:t>
             </a:r>
           </a:p>
           <a:p>
-            <a:pPr/>
-            <a:r>
+            <a:pPr>
+              <a:spcAft>
+                <a:spcPts val="800"/>
+              </a:spcAft>
+            </a:pPr>
+            <a:r>
+              <a:rPr sz="1500">
+                <a:solidFill>
+                  <a:srgbClr val="2C2C2E"/>
+                </a:solidFill>
+                <a:latin typeface="Calibri"/>
+              </a:rPr>
               <a:t>GeeksforGeeks Python: https://www.geeksforgeeks.org/python/</a:t>
             </a:r>
           </a:p>
           <a:p>
-            <a:pPr/>
-            <a:r>
+            <a:pPr>
+              <a:spcAft>
+                <a:spcPts val="800"/>
+              </a:spcAft>
+            </a:pPr>
+            <a:r>
+              <a:rPr sz="1500">
+                <a:solidFill>
+                  <a:srgbClr val="2C2C2E"/>
+                </a:solidFill>
+                <a:latin typeface="Calibri"/>
+              </a:rPr>
               <a:t>W3Schools Python: https://www.w3schools.com/python/</a:t>
             </a:r>
           </a:p>
@@ -3944,6 +4042,14 @@
 <file path=ppt/slides/slide2.xml><?xml version="1.0" encoding="utf-8"?>
 <p:sld xmlns:a="http://schemas.openxmlformats.org/drawingml/2006/main" xmlns:p="http://schemas.openxmlformats.org/presentationml/2006/main" xmlns:r="http://schemas.openxmlformats.org/officeDocument/2006/relationships">
   <p:cSld>
+    <p:bg>
+      <p:bgPr>
+        <a:solidFill>
+          <a:srgbClr val="F5F8FC"/>
+        </a:solidFill>
+        <a:effectLst/>
+      </p:bgPr>
+    </p:bg>
     <p:spTree>
       <p:nvGrpSpPr>
         <p:cNvPr id="1" name=""/>
@@ -3963,10 +4069,21 @@
         </p:nvSpPr>
         <p:spPr/>
         <p:txBody>
-          <a:bodyPr/>
-          <a:lstStyle/>
-          <a:p>
-            <a:r>
+          <a:bodyPr wrap="square"/>
+          <a:lstStyle/>
+          <a:p>
+            <a:pPr>
+              <a:spcAft>
+                <a:spcPts val="600"/>
+              </a:spcAft>
+            </a:pPr>
+            <a:r>
+              <a:rPr sz="2600" b="1">
+                <a:solidFill>
+                  <a:srgbClr val="15436C"/>
+                </a:solidFill>
+                <a:latin typeface="Calibri"/>
+              </a:rPr>
               <a:t>Learning objectives</a:t>
             </a:r>
           </a:p>
@@ -3986,22 +4103,51 @@
         <p:txBody>
           <a:bodyPr/>
           <a:lstStyle/>
-          <a:p/>
-          <a:p>
-            <a:pPr/>
-            <a:r>
+          <a:p>
+            <a:pPr>
+              <a:spcAft>
+                <a:spcPts val="1000"/>
+              </a:spcAft>
+            </a:pPr>
+            <a:r>
+              <a:rPr sz="1800">
+                <a:solidFill>
+                  <a:srgbClr val="2C2C2E"/>
+                </a:solidFill>
+                <a:latin typeface="Calibri"/>
+              </a:rPr>
               <a:t>Organize data using tuples, sets, and dictionaries.</a:t>
             </a:r>
           </a:p>
           <a:p>
-            <a:pPr/>
-            <a:r>
+            <a:pPr>
+              <a:spcAft>
+                <a:spcPts val="1000"/>
+              </a:spcAft>
+            </a:pPr>
+            <a:r>
+              <a:rPr sz="1800">
+                <a:solidFill>
+                  <a:srgbClr val="2C2C2E"/>
+                </a:solidFill>
+                <a:latin typeface="Calibri"/>
+              </a:rPr>
               <a:t>Choose the right structure for policy and management data (schemes, beneficiaries, surveys).</a:t>
             </a:r>
           </a:p>
           <a:p>
-            <a:pPr/>
-            <a:r>
+            <a:pPr>
+              <a:spcAft>
+                <a:spcPts val="1000"/>
+              </a:spcAft>
+            </a:pPr>
+            <a:r>
+              <a:rPr sz="1800">
+                <a:solidFill>
+                  <a:srgbClr val="2C2C2E"/>
+                </a:solidFill>
+                <a:latin typeface="Calibri"/>
+              </a:rPr>
               <a:t>Apply to real-world tasks: unique stakeholders, scheme lookups, survey response counts.</a:t>
             </a:r>
           </a:p>
@@ -4018,6 +4164,14 @@
 <file path=ppt/slides/slide3.xml><?xml version="1.0" encoding="utf-8"?>
 <p:sld xmlns:a="http://schemas.openxmlformats.org/drawingml/2006/main" xmlns:p="http://schemas.openxmlformats.org/presentationml/2006/main" xmlns:r="http://schemas.openxmlformats.org/officeDocument/2006/relationships">
   <p:cSld>
+    <p:bg>
+      <p:bgPr>
+        <a:solidFill>
+          <a:srgbClr val="F5F8FC"/>
+        </a:solidFill>
+        <a:effectLst/>
+      </p:bgPr>
+    </p:bg>
     <p:spTree>
       <p:nvGrpSpPr>
         <p:cNvPr id="1" name=""/>
@@ -4037,10 +4191,21 @@
         </p:nvSpPr>
         <p:spPr/>
         <p:txBody>
-          <a:bodyPr/>
-          <a:lstStyle/>
-          <a:p>
-            <a:r>
+          <a:bodyPr wrap="square"/>
+          <a:lstStyle/>
+          <a:p>
+            <a:pPr>
+              <a:spcAft>
+                <a:spcPts val="600"/>
+              </a:spcAft>
+            </a:pPr>
+            <a:r>
+              <a:rPr sz="2600" b="1">
+                <a:solidFill>
+                  <a:srgbClr val="15436C"/>
+                </a:solidFill>
+                <a:latin typeface="Calibri"/>
+              </a:rPr>
               <a:t>Tuples – management &amp; policy use</a:t>
             </a:r>
           </a:p>
@@ -4060,22 +4225,51 @@
         <p:txBody>
           <a:bodyPr/>
           <a:lstStyle/>
-          <a:p/>
-          <a:p>
-            <a:pPr/>
-            <a:r>
+          <a:p>
+            <a:pPr>
+              <a:spcAft>
+                <a:spcPts val="1000"/>
+              </a:spcAft>
+            </a:pPr>
+            <a:r>
+              <a:rPr sz="1800">
+                <a:solidFill>
+                  <a:srgbClr val="2C2C2E"/>
+                </a:solidFill>
+                <a:latin typeface="Calibri"/>
+              </a:rPr>
               <a:t>Immutable ordered sequence: (scheme_name, year, budget) — e.g. one fixed record.</a:t>
             </a:r>
           </a:p>
           <a:p>
-            <a:pPr/>
-            <a:r>
+            <a:pPr>
+              <a:spcAft>
+                <a:spcPts val="1000"/>
+              </a:spcAft>
+            </a:pPr>
+            <a:r>
+              <a:rPr sz="1800">
+                <a:solidFill>
+                  <a:srgbClr val="2C2C2E"/>
+                </a:solidFill>
+                <a:latin typeface="Calibri"/>
+              </a:rPr>
               <a:t>Use when: order matters and data should not change (e.g. policy snapshot, KPI row).</a:t>
             </a:r>
           </a:p>
           <a:p>
-            <a:pPr/>
-            <a:r>
+            <a:pPr>
+              <a:spcAft>
+                <a:spcPts val="1000"/>
+              </a:spcAft>
+            </a:pPr>
+            <a:r>
+              <a:rPr sz="1800">
+                <a:solidFill>
+                  <a:srgbClr val="2C2C2E"/>
+                </a:solidFill>
+                <a:latin typeface="Calibri"/>
+              </a:rPr>
               <a:t>Unpacking: scheme_name, year, budget = policy_record.</a:t>
             </a:r>
           </a:p>
@@ -4092,6 +4286,14 @@
 <file path=ppt/slides/slide4.xml><?xml version="1.0" encoding="utf-8"?>
 <p:sld xmlns:a="http://schemas.openxmlformats.org/drawingml/2006/main" xmlns:p="http://schemas.openxmlformats.org/presentationml/2006/main" xmlns:r="http://schemas.openxmlformats.org/officeDocument/2006/relationships">
   <p:cSld>
+    <p:bg>
+      <p:bgPr>
+        <a:solidFill>
+          <a:srgbClr val="F5F8FC"/>
+        </a:solidFill>
+        <a:effectLst/>
+      </p:bgPr>
+    </p:bg>
     <p:spTree>
       <p:nvGrpSpPr>
         <p:cNvPr id="1" name=""/>
@@ -4111,10 +4313,21 @@
         </p:nvSpPr>
         <p:spPr/>
         <p:txBody>
-          <a:bodyPr/>
-          <a:lstStyle/>
-          <a:p>
-            <a:r>
+          <a:bodyPr wrap="square"/>
+          <a:lstStyle/>
+          <a:p>
+            <a:pPr>
+              <a:spcAft>
+                <a:spcPts val="600"/>
+              </a:spcAft>
+            </a:pPr>
+            <a:r>
+              <a:rPr sz="2600" b="1">
+                <a:solidFill>
+                  <a:srgbClr val="15436C"/>
+                </a:solidFill>
+                <a:latin typeface="Calibri"/>
+              </a:rPr>
               <a:t>Sets – unique entities</a:t>
             </a:r>
           </a:p>
@@ -4134,22 +4347,51 @@
         <p:txBody>
           <a:bodyPr/>
           <a:lstStyle/>
-          <a:p/>
-          <a:p>
-            <a:pPr/>
-            <a:r>
+          <a:p>
+            <a:pPr>
+              <a:spcAft>
+                <a:spcPts val="1000"/>
+              </a:spcAft>
+            </a:pPr>
+            <a:r>
+              <a:rPr sz="1800">
+                <a:solidFill>
+                  <a:srgbClr val="2C2C2E"/>
+                </a:solidFill>
+                <a:latin typeface="Calibri"/>
+              </a:rPr>
               <a:t>Unordered collection of unique elements: e.g. unique beneficiary IDs, districts, departments.</a:t>
             </a:r>
           </a:p>
           <a:p>
-            <a:pPr/>
-            <a:r>
+            <a:pPr>
+              <a:spcAft>
+                <a:spcPts val="1000"/>
+              </a:spcAft>
+            </a:pPr>
+            <a:r>
+              <a:rPr sz="1800">
+                <a:solidFill>
+                  <a:srgbClr val="2C2C2E"/>
+                </a:solidFill>
+                <a:latin typeface="Calibri"/>
+              </a:rPr>
               <a:t>Use when: counting distinct stakeholders, regions covered, or removing duplicate responses.</a:t>
             </a:r>
           </a:p>
           <a:p>
-            <a:pPr/>
-            <a:r>
+            <a:pPr>
+              <a:spcAft>
+                <a:spcPts val="1000"/>
+              </a:spcAft>
+            </a:pPr>
+            <a:r>
+              <a:rPr sz="1800">
+                <a:solidFill>
+                  <a:srgbClr val="2C2C2E"/>
+                </a:solidFill>
+                <a:latin typeface="Calibri"/>
+              </a:rPr>
               <a:t>Operations: union (combined coverage), intersection (common beneficiaries), difference.</a:t>
             </a:r>
           </a:p>
@@ -4166,6 +4408,14 @@
 <file path=ppt/slides/slide5.xml><?xml version="1.0" encoding="utf-8"?>
 <p:sld xmlns:a="http://schemas.openxmlformats.org/drawingml/2006/main" xmlns:p="http://schemas.openxmlformats.org/presentationml/2006/main" xmlns:r="http://schemas.openxmlformats.org/officeDocument/2006/relationships">
   <p:cSld>
+    <p:bg>
+      <p:bgPr>
+        <a:solidFill>
+          <a:srgbClr val="F5F8FC"/>
+        </a:solidFill>
+        <a:effectLst/>
+      </p:bgPr>
+    </p:bg>
     <p:spTree>
       <p:nvGrpSpPr>
         <p:cNvPr id="1" name=""/>
@@ -4185,10 +4435,21 @@
         </p:nvSpPr>
         <p:spPr/>
         <p:txBody>
-          <a:bodyPr/>
-          <a:lstStyle/>
-          <a:p>
-            <a:r>
+          <a:bodyPr wrap="square"/>
+          <a:lstStyle/>
+          <a:p>
+            <a:pPr>
+              <a:spcAft>
+                <a:spcPts val="600"/>
+              </a:spcAft>
+            </a:pPr>
+            <a:r>
+              <a:rPr sz="2600" b="1">
+                <a:solidFill>
+                  <a:srgbClr val="15436C"/>
+                </a:solidFill>
+                <a:latin typeface="Calibri"/>
+              </a:rPr>
               <a:t>Dictionaries – key–value lookups</a:t>
             </a:r>
           </a:p>
@@ -4208,22 +4469,51 @@
         <p:txBody>
           <a:bodyPr/>
           <a:lstStyle/>
-          <a:p/>
-          <a:p>
-            <a:pPr/>
-            <a:r>
+          <a:p>
+            <a:pPr>
+              <a:spcAft>
+                <a:spcPts val="1000"/>
+              </a:spcAft>
+            </a:pPr>
+            <a:r>
+              <a:rPr sz="1800">
+                <a:solidFill>
+                  <a:srgbClr val="2C2C2E"/>
+                </a:solidFill>
+                <a:latin typeface="Calibri"/>
+              </a:rPr>
               <a:t>Key–value pairs: scheme_id → details, department → head, indicator → target.</a:t>
             </a:r>
           </a:p>
           <a:p>
-            <a:pPr/>
-            <a:r>
+            <a:pPr>
+              <a:spcAft>
+                <a:spcPts val="1000"/>
+              </a:spcAft>
+            </a:pPr>
+            <a:r>
+              <a:rPr sz="1800">
+                <a:solidFill>
+                  <a:srgbClr val="2C2C2E"/>
+                </a:solidFill>
+                <a:latin typeface="Calibri"/>
+              </a:rPr>
               <a:t>Use when: looking up policy details, program metadata, or survey codes by ID.</a:t>
             </a:r>
           </a:p>
           <a:p>
-            <a:pPr/>
-            <a:r>
+            <a:pPr>
+              <a:spcAft>
+                <a:spcPts val="1000"/>
+              </a:spcAft>
+            </a:pPr>
+            <a:r>
+              <a:rPr sz="1800">
+                <a:solidFill>
+                  <a:srgbClr val="2C2C2E"/>
+                </a:solidFill>
+                <a:latin typeface="Calibri"/>
+              </a:rPr>
               <a:t>.keys(), .values(), .items() for reporting and iteration.</a:t>
             </a:r>
           </a:p>
@@ -4240,6 +4530,14 @@
 <file path=ppt/slides/slide6.xml><?xml version="1.0" encoding="utf-8"?>
 <p:sld xmlns:a="http://schemas.openxmlformats.org/drawingml/2006/main" xmlns:p="http://schemas.openxmlformats.org/presentationml/2006/main" xmlns:r="http://schemas.openxmlformats.org/officeDocument/2006/relationships">
   <p:cSld>
+    <p:bg>
+      <p:bgPr>
+        <a:solidFill>
+          <a:srgbClr val="F5F8FC"/>
+        </a:solidFill>
+        <a:effectLst/>
+      </p:bgPr>
+    </p:bg>
     <p:spTree>
       <p:nvGrpSpPr>
         <p:cNvPr id="1" name=""/>
@@ -4259,10 +4557,21 @@
         </p:nvSpPr>
         <p:spPr/>
         <p:txBody>
-          <a:bodyPr/>
-          <a:lstStyle/>
-          <a:p>
-            <a:r>
+          <a:bodyPr wrap="square"/>
+          <a:lstStyle/>
+          <a:p>
+            <a:pPr>
+              <a:spcAft>
+                <a:spcPts val="600"/>
+              </a:spcAft>
+            </a:pPr>
+            <a:r>
+              <a:rPr sz="2600" b="1">
+                <a:solidFill>
+                  <a:srgbClr val="15436C"/>
+                </a:solidFill>
+                <a:latin typeface="Calibri"/>
+              </a:rPr>
               <a:t>Under the hood: Tuples, Sets, Dictionaries</a:t>
             </a:r>
           </a:p>
@@ -4282,22 +4591,51 @@
         <p:txBody>
           <a:bodyPr/>
           <a:lstStyle/>
-          <a:p/>
-          <a:p>
-            <a:pPr/>
-            <a:r>
+          <a:p>
+            <a:pPr>
+              <a:spcAft>
+                <a:spcPts val="1000"/>
+              </a:spcAft>
+            </a:pPr>
+            <a:r>
+              <a:rPr sz="1800">
+                <a:solidFill>
+                  <a:srgbClr val="2C2C2E"/>
+                </a:solidFill>
+                <a:latin typeface="Calibri"/>
+              </a:rPr>
               <a:t>Tuple: immutable, fixed sequence; hashable if elements are hashable; O(1) index access.</a:t>
             </a:r>
           </a:p>
           <a:p>
-            <a:pPr/>
-            <a:r>
+            <a:pPr>
+              <a:spcAft>
+                <a:spcPts val="1000"/>
+              </a:spcAft>
+            </a:pPr>
+            <a:r>
+              <a:rPr sz="1800">
+                <a:solidFill>
+                  <a:srgbClr val="2C2C2E"/>
+                </a:solidFill>
+                <a:latin typeface="Calibri"/>
+              </a:rPr>
               <a:t>Set: hash table; O(1) membership; elements must be hashable; order not guaranteed.</a:t>
             </a:r>
           </a:p>
           <a:p>
-            <a:pPr/>
-            <a:r>
+            <a:pPr>
+              <a:spcAft>
+                <a:spcPts val="1000"/>
+              </a:spcAft>
+            </a:pPr>
+            <a:r>
+              <a:rPr sz="1800">
+                <a:solidFill>
+                  <a:srgbClr val="2C2C2E"/>
+                </a:solidFill>
+                <a:latin typeface="Calibri"/>
+              </a:rPr>
               <a:t>Dict: hash table; O(1) lookup by key; keys must be hashable; insertion order preserved (3.7+).</a:t>
             </a:r>
           </a:p>
@@ -4314,6 +4652,14 @@
 <file path=ppt/slides/slide7.xml><?xml version="1.0" encoding="utf-8"?>
 <p:sld xmlns:a="http://schemas.openxmlformats.org/drawingml/2006/main" xmlns:p="http://schemas.openxmlformats.org/presentationml/2006/main" xmlns:r="http://schemas.openxmlformats.org/officeDocument/2006/relationships">
   <p:cSld>
+    <p:bg>
+      <p:bgPr>
+        <a:solidFill>
+          <a:srgbClr val="F5F8FC"/>
+        </a:solidFill>
+        <a:effectLst/>
+      </p:bgPr>
+    </p:bg>
     <p:spTree>
       <p:nvGrpSpPr>
         <p:cNvPr id="1" name=""/>
@@ -4333,10 +4679,21 @@
         </p:nvSpPr>
         <p:spPr/>
         <p:txBody>
-          <a:bodyPr/>
-          <a:lstStyle/>
-          <a:p>
-            <a:r>
+          <a:bodyPr wrap="square"/>
+          <a:lstStyle/>
+          <a:p>
+            <a:pPr>
+              <a:spcAft>
+                <a:spcPts val="600"/>
+              </a:spcAft>
+            </a:pPr>
+            <a:r>
+              <a:rPr sz="2600" b="1">
+                <a:solidFill>
+                  <a:srgbClr val="15436C"/>
+                </a:solidFill>
+                <a:latin typeface="Calibri"/>
+              </a:rPr>
               <a:t>When to use which? (management &amp; policy)</a:t>
             </a:r>
           </a:p>
@@ -4356,22 +4713,51 @@
         <p:txBody>
           <a:bodyPr/>
           <a:lstStyle/>
-          <a:p/>
-          <a:p>
-            <a:pPr/>
-            <a:r>
+          <a:p>
+            <a:pPr>
+              <a:spcAft>
+                <a:spcPts val="1000"/>
+              </a:spcAft>
+            </a:pPr>
+            <a:r>
+              <a:rPr sz="1800">
+                <a:solidFill>
+                  <a:srgbClr val="2C2C2E"/>
+                </a:solidFill>
+                <a:latin typeface="Calibri"/>
+              </a:rPr>
               <a:t>Tuple: one fixed record (e.g. scheme name, financial year, allocated amount).</a:t>
             </a:r>
           </a:p>
           <a:p>
-            <a:pPr/>
-            <a:r>
+            <a:pPr>
+              <a:spcAft>
+                <a:spcPts val="1000"/>
+              </a:spcAft>
+            </a:pPr>
+            <a:r>
+              <a:rPr sz="1800">
+                <a:solidFill>
+                  <a:srgbClr val="2C2C2E"/>
+                </a:solidFill>
+                <a:latin typeface="Calibri"/>
+              </a:rPr>
               <a:t>Set: unique beneficiaries, unique districts in a program, unique response categories.</a:t>
             </a:r>
           </a:p>
           <a:p>
-            <a:pPr/>
-            <a:r>
+            <a:pPr>
+              <a:spcAft>
+                <a:spcPts val="1000"/>
+              </a:spcAft>
+            </a:pPr>
+            <a:r>
+              <a:rPr sz="1800">
+                <a:solidFill>
+                  <a:srgbClr val="2C2C2E"/>
+                </a:solidFill>
+                <a:latin typeface="Calibri"/>
+              </a:rPr>
               <a:t>Dict: scheme_id → full details; department → contact; indicator_code → definition.</a:t>
             </a:r>
           </a:p>
@@ -4388,6 +4774,14 @@
 <file path=ppt/slides/slide8.xml><?xml version="1.0" encoding="utf-8"?>
 <p:sld xmlns:a="http://schemas.openxmlformats.org/drawingml/2006/main" xmlns:p="http://schemas.openxmlformats.org/presentationml/2006/main" xmlns:r="http://schemas.openxmlformats.org/officeDocument/2006/relationships">
   <p:cSld>
+    <p:bg>
+      <p:bgPr>
+        <a:solidFill>
+          <a:srgbClr val="F5F8FC"/>
+        </a:solidFill>
+        <a:effectLst/>
+      </p:bgPr>
+    </p:bg>
     <p:spTree>
       <p:nvGrpSpPr>
         <p:cNvPr id="1" name=""/>
@@ -4407,10 +4801,21 @@
         </p:nvSpPr>
         <p:spPr/>
         <p:txBody>
-          <a:bodyPr/>
-          <a:lstStyle/>
-          <a:p>
-            <a:r>
+          <a:bodyPr wrap="square"/>
+          <a:lstStyle/>
+          <a:p>
+            <a:pPr>
+              <a:spcAft>
+                <a:spcPts val="600"/>
+              </a:spcAft>
+            </a:pPr>
+            <a:r>
+              <a:rPr sz="2600" b="1">
+                <a:solidFill>
+                  <a:srgbClr val="15436C"/>
+                </a:solidFill>
+                <a:latin typeface="Calibri"/>
+              </a:rPr>
               <a:t>Practical in-class (Colab)</a:t>
             </a:r>
           </a:p>
@@ -4430,22 +4835,51 @@
         <p:txBody>
           <a:bodyPr/>
           <a:lstStyle/>
-          <a:p/>
-          <a:p>
-            <a:pPr/>
-            <a:r>
+          <a:p>
+            <a:pPr>
+              <a:spcAft>
+                <a:spcPts val="1000"/>
+              </a:spcAft>
+            </a:pPr>
+            <a:r>
+              <a:rPr sz="1800">
+                <a:solidFill>
+                  <a:srgbClr val="2C2C2E"/>
+                </a:solidFill>
+                <a:latin typeface="Calibri"/>
+              </a:rPr>
               <a:t>Session 8 Student notebook: tuples (policy record), sets (unique regions/beneficiaries), dicts (scheme lookup).</a:t>
             </a:r>
           </a:p>
           <a:p>
-            <a:pPr/>
-            <a:r>
+            <a:pPr>
+              <a:spcAft>
+                <a:spcPts val="1000"/>
+              </a:spcAft>
+            </a:pPr>
+            <a:r>
+              <a:rPr sz="1800">
+                <a:solidFill>
+                  <a:srgbClr val="2C2C2E"/>
+                </a:solidFill>
+                <a:latin typeface="Calibri"/>
+              </a:rPr>
               <a:t>Hands-on: e.g. count unique districts in a program, build a scheme lookup table.</a:t>
             </a:r>
           </a:p>
           <a:p>
-            <a:pPr/>
-            <a:r>
+            <a:pPr>
+              <a:spcAft>
+                <a:spcPts val="1000"/>
+              </a:spcAft>
+            </a:pPr>
+            <a:r>
+              <a:rPr sz="1800">
+                <a:solidFill>
+                  <a:srgbClr val="2C2C2E"/>
+                </a:solidFill>
+                <a:latin typeface="Calibri"/>
+              </a:rPr>
               <a:t>All examples use business management and public policy contexts.</a:t>
             </a:r>
           </a:p>
@@ -4462,6 +4896,14 @@
 <file path=ppt/slides/slide9.xml><?xml version="1.0" encoding="utf-8"?>
 <p:sld xmlns:a="http://schemas.openxmlformats.org/drawingml/2006/main" xmlns:p="http://schemas.openxmlformats.org/presentationml/2006/main" xmlns:r="http://schemas.openxmlformats.org/officeDocument/2006/relationships">
   <p:cSld>
+    <p:bg>
+      <p:bgPr>
+        <a:solidFill>
+          <a:srgbClr val="F5F8FC"/>
+        </a:solidFill>
+        <a:effectLst/>
+      </p:bgPr>
+    </p:bg>
     <p:spTree>
       <p:nvGrpSpPr>
         <p:cNvPr id="1" name=""/>
@@ -4481,10 +4923,21 @@
         </p:nvSpPr>
         <p:spPr/>
         <p:txBody>
-          <a:bodyPr/>
-          <a:lstStyle/>
-          <a:p>
-            <a:r>
+          <a:bodyPr wrap="square"/>
+          <a:lstStyle/>
+          <a:p>
+            <a:pPr>
+              <a:spcAft>
+                <a:spcPts val="600"/>
+              </a:spcAft>
+            </a:pPr>
+            <a:r>
+              <a:rPr sz="2600" b="1">
+                <a:solidFill>
+                  <a:srgbClr val="15436C"/>
+                </a:solidFill>
+                <a:latin typeface="Calibri"/>
+              </a:rPr>
               <a:t>Session 8 – Recap</a:t>
             </a:r>
           </a:p>
@@ -4504,22 +4957,51 @@
         <p:txBody>
           <a:bodyPr/>
           <a:lstStyle/>
-          <a:p/>
-          <a:p>
-            <a:pPr/>
-            <a:r>
+          <a:p>
+            <a:pPr>
+              <a:spcAft>
+                <a:spcPts val="1000"/>
+              </a:spcAft>
+            </a:pPr>
+            <a:r>
+              <a:rPr sz="1800">
+                <a:solidFill>
+                  <a:srgbClr val="2C2C2E"/>
+                </a:solidFill>
+                <a:latin typeface="Calibri"/>
+              </a:rPr>
               <a:t>Tuples: immutable, ordered.</a:t>
             </a:r>
           </a:p>
           <a:p>
-            <a:pPr/>
-            <a:r>
+            <a:pPr>
+              <a:spcAft>
+                <a:spcPts val="1000"/>
+              </a:spcAft>
+            </a:pPr>
+            <a:r>
+              <a:rPr sz="1800">
+                <a:solidFill>
+                  <a:srgbClr val="2C2C2E"/>
+                </a:solidFill>
+                <a:latin typeface="Calibri"/>
+              </a:rPr>
               <a:t>Sets: unique, unordered, fast membership.</a:t>
             </a:r>
           </a:p>
           <a:p>
-            <a:pPr/>
-            <a:r>
+            <a:pPr>
+              <a:spcAft>
+                <a:spcPts val="1000"/>
+              </a:spcAft>
+            </a:pPr>
+            <a:r>
+              <a:rPr sz="1800">
+                <a:solidFill>
+                  <a:srgbClr val="2C2C2E"/>
+                </a:solidFill>
+                <a:latin typeface="Calibri"/>
+              </a:rPr>
               <a:t>Dictionaries: key–value, fast lookup by key.</a:t>
             </a:r>
           </a:p>

</xml_diff>